<commit_message>
feat: resolve event date dynamically from database for certificates
</commit_message>
<xml_diff>
--- a/CERTIFICATE_TEMPLATE - Volunteers.pptx
+++ b/CERTIFICATE_TEMPLATE - Volunteers.pptx
@@ -3497,7 +3497,7 @@
         </p:nvSpPr>
         <p:spPr>
           <a:xfrm>
-            <a:off x="0" y="0"/>
+            <a:off x="0" y="76200"/>
             <a:ext cx="10693400" cy="7605395"/>
           </a:xfrm>
           <a:custGeom>
@@ -4350,52 +4350,6 @@
       </p:sp>
       <p:sp>
         <p:nvSpPr>
-          <p:cNvPr id="28" name="Freeform 28"/>
-          <p:cNvSpPr/>
-          <p:nvPr/>
-        </p:nvSpPr>
-        <p:spPr>
-          <a:xfrm>
-            <a:off x="955730" y="1529822"/>
-            <a:ext cx="773426" cy="817169"/>
-          </a:xfrm>
-          <a:custGeom>
-            <a:avLst/>
-            <a:gdLst/>
-            <a:ahLst/>
-            <a:cxnLst/>
-            <a:rect l="l" t="t" r="r" b="b"/>
-            <a:pathLst>
-              <a:path w="773426" h="817169">
-                <a:moveTo>
-                  <a:pt x="0" y="0"/>
-                </a:moveTo>
-                <a:lnTo>
-                  <a:pt x="773426" y="0"/>
-                </a:lnTo>
-                <a:lnTo>
-                  <a:pt x="773426" y="817169"/>
-                </a:lnTo>
-                <a:lnTo>
-                  <a:pt x="0" y="817169"/>
-                </a:lnTo>
-                <a:lnTo>
-                  <a:pt x="0" y="0"/>
-                </a:lnTo>
-                <a:close/>
-              </a:path>
-            </a:pathLst>
-          </a:custGeom>
-          <a:blipFill>
-            <a:blip r:embed="rId15"/>
-            <a:stretch>
-              <a:fillRect/>
-            </a:stretch>
-          </a:blipFill>
-        </p:spPr>
-      </p:sp>
-      <p:sp>
-        <p:nvSpPr>
           <p:cNvPr id="29" name="Freeform 29"/>
           <p:cNvSpPr/>
           <p:nvPr/>
@@ -4433,7 +4387,7 @@
             </a:pathLst>
           </a:custGeom>
           <a:blipFill>
-            <a:blip r:embed="rId16"/>
+            <a:blip r:embed="rId15"/>
             <a:stretch>
               <a:fillRect/>
             </a:stretch>
@@ -4479,7 +4433,7 @@
             </a:pathLst>
           </a:custGeom>
           <a:blipFill>
-            <a:blip r:embed="rId17"/>
+            <a:blip r:embed="rId16"/>
             <a:stretch>
               <a:fillRect/>
             </a:stretch>
@@ -4572,7 +4526,43 @@
                 <a:cs typeface="Cardo" panose="02020600000000000000"/>
                 <a:sym typeface="Cardo" panose="02020600000000000000"/>
               </a:rPr>
-              <a:t>We sincerely appreciate your dedicated service, active participation, and valuable contribution as an official Volunteer for the {{EVENT NAME}}, organized by Trinity College of Engineering and Technology – Automation, Peddapalli, and held on {{DATE}}.</a:t>
+              <a:t>We sincerely appreciate your dedicated service, active participation, and valuable contribution as an official Volunteer for the {{EVENT NAME}}, organized by Trinity College of Engineering and Technology – </a:t>
+            </a:r>
+            <a:r>
+              <a:rPr lang="en-US" altLang="en-US" sz="1280">
+                <a:solidFill>
+                  <a:srgbClr val="0D1E4A"/>
+                </a:solidFill>
+                <a:latin typeface="Cardo" panose="02020600000000000000"/>
+                <a:ea typeface="Cardo" panose="02020600000000000000"/>
+                <a:cs typeface="Cardo" panose="02020600000000000000"/>
+                <a:sym typeface="Cardo" panose="02020600000000000000"/>
+              </a:rPr>
+              <a:t>Auto</a:t>
+            </a:r>
+            <a:r>
+              <a:rPr lang="en-IN" altLang="en-US" sz="1280">
+                <a:solidFill>
+                  <a:srgbClr val="0D1E4A"/>
+                </a:solidFill>
+                <a:latin typeface="Cardo" panose="02020600000000000000"/>
+                <a:ea typeface="Cardo" panose="02020600000000000000"/>
+                <a:cs typeface="Cardo" panose="02020600000000000000"/>
+                <a:sym typeface="Cardo" panose="02020600000000000000"/>
+              </a:rPr>
+              <a:t>nomous</a:t>
+            </a:r>
+            <a:r>
+              <a:rPr lang="en-US" altLang="en-US" sz="1280">
+                <a:solidFill>
+                  <a:srgbClr val="0D1E4A"/>
+                </a:solidFill>
+                <a:latin typeface="Cardo" panose="02020600000000000000"/>
+                <a:ea typeface="Cardo" panose="02020600000000000000"/>
+                <a:cs typeface="Cardo" panose="02020600000000000000"/>
+                <a:sym typeface="Cardo" panose="02020600000000000000"/>
+              </a:rPr>
+              <a:t>, Peddapalli, and held on {{DATE}}.</a:t>
             </a:r>
             <a:endParaRPr lang="en-US" altLang="en-US" sz="1280">
               <a:solidFill>
@@ -4713,7 +4703,7 @@
               </a:pathLst>
             </a:custGeom>
             <a:blipFill>
-              <a:blip r:embed="rId18"/>
+              <a:blip r:embed="rId17"/>
               <a:stretch>
                 <a:fillRect b="-9"/>
               </a:stretch>
@@ -5391,7 +5381,7 @@
         </p:nvSpPr>
         <p:spPr>
           <a:xfrm>
-            <a:off x="4539310" y="7240114"/>
+            <a:off x="4539310" y="7392514"/>
             <a:ext cx="2035254" cy="133350"/>
           </a:xfrm>
           <a:prstGeom prst="rect">

</xml_diff>